<commit_message>
Restructure slide deck into standard 5-part format
</commit_message>
<xml_diff>
--- a/reports/AVM_house_valuation.pptx
+++ b/reports/AVM_house_valuation.pptx
@@ -11,8 +11,6 @@
     <p:sldId id="259" r:id="rId10"/>
     <p:sldId id="260" r:id="rId11"/>
     <p:sldId id="261" r:id="rId12"/>
-    <p:sldId id="262" r:id="rId13"/>
-    <p:sldId id="263" r:id="rId14"/>
   </p:sldIdLst>
   <p:sldSz cx="12191695" cy="6858000" type="screen4x3"/>
   <p:notesSz cx="6858000" cy="9144000"/>
@@ -3091,7 +3089,7 @@
     <p:bg>
       <p:bgPr>
         <a:solidFill>
-          <a:srgbClr val="FFFFFF"/>
+          <a:srgbClr val="0F172A"/>
         </a:solidFill>
         <a:effectLst/>
       </p:bgPr>
@@ -3105,57 +3103,14 @@
       <p:grpSpPr/>
       <p:sp>
         <p:nvSpPr>
-          <p:cNvPr id="2" name="Rectangle 1"/>
-          <p:cNvSpPr/>
-          <p:nvPr/>
-        </p:nvSpPr>
-        <p:spPr>
-          <a:xfrm>
-            <a:off x="0" y="0"/>
-            <a:ext cx="12191695" cy="6858000"/>
-          </a:xfrm>
-          <a:prstGeom prst="rect">
-            <a:avLst/>
-          </a:prstGeom>
-          <a:solidFill>
-            <a:srgbClr val="0F172A"/>
-          </a:solidFill>
-          <a:ln>
-            <a:noFill/>
-          </a:ln>
-        </p:spPr>
-        <p:style>
-          <a:lnRef idx="1">
-            <a:schemeClr val="accent1"/>
-          </a:lnRef>
-          <a:fillRef idx="3">
-            <a:schemeClr val="accent1"/>
-          </a:fillRef>
-          <a:effectRef idx="2">
-            <a:schemeClr val="accent1"/>
-          </a:effectRef>
-          <a:fontRef idx="minor">
-            <a:schemeClr val="lt1"/>
-          </a:fontRef>
-        </p:style>
-        <p:txBody>
-          <a:bodyPr rtlCol="0" anchor="ctr"/>
-          <a:lstStyle/>
-          <a:p>
-            <a:pPr algn="ctr"/>
-          </a:p>
-        </p:txBody>
-      </p:sp>
-      <p:sp>
-        <p:nvSpPr>
-          <p:cNvPr id="3" name="TextBox 2"/>
+          <p:cNvPr id="2" name="TextBox 1"/>
           <p:cNvSpPr txBox="1"/>
           <p:nvPr/>
         </p:nvSpPr>
         <p:spPr>
           <a:xfrm>
-            <a:off x="731520" y="2103120"/>
-            <a:ext cx="10698480" cy="1280160"/>
+            <a:off x="822960" y="2103120"/>
+            <a:ext cx="10607040" cy="1188720"/>
           </a:xfrm>
           <a:prstGeom prst="rect">
             <a:avLst/>
@@ -3176,21 +3131,21 @@
                 </a:solidFill>
                 <a:latin typeface="Calibri"/>
               </a:rPr>
-              <a:t>🏠  Melbourne Automated Valuation Model</a:t>
-            </a:r>
-          </a:p>
-        </p:txBody>
-      </p:sp>
-      <p:sp>
-        <p:nvSpPr>
-          <p:cNvPr id="4" name="TextBox 3"/>
+              <a:t>🏠  Automated Valuation Model</a:t>
+            </a:r>
+          </a:p>
+        </p:txBody>
+      </p:sp>
+      <p:sp>
+        <p:nvSpPr>
+          <p:cNvPr id="3" name="TextBox 2"/>
           <p:cNvSpPr txBox="1"/>
           <p:nvPr/>
         </p:nvSpPr>
         <p:spPr>
           <a:xfrm>
-            <a:off x="777240" y="3383280"/>
-            <a:ext cx="10515600" cy="914400"/>
+            <a:off x="868680" y="3383280"/>
+            <a:ext cx="10424160" cy="914400"/>
           </a:xfrm>
           <a:prstGeom prst="rect">
             <a:avLst/>
@@ -3207,25 +3162,25 @@
             <a:r>
               <a:rPr sz="1800" b="0">
                 <a:solidFill>
-                  <a:srgbClr val="CBD5E1"/>
+                  <a:srgbClr val="E2E8F0"/>
                 </a:solidFill>
                 <a:latin typeface="Calibri"/>
               </a:rPr>
-              <a:t>Explainable, uncertainty-aware property pricing — the AVM class behind Zestimate, Redfin and lender valuation engines.</a:t>
-            </a:r>
-          </a:p>
-        </p:txBody>
-      </p:sp>
-      <p:sp>
-        <p:nvSpPr>
-          <p:cNvPr id="5" name="TextBox 4"/>
+              <a:t>Explainable, uncertainty-aware residential property valuation — the AVM class behind Zestimate, Redfin and lender pricing engines.</a:t>
+            </a:r>
+          </a:p>
+        </p:txBody>
+      </p:sp>
+      <p:sp>
+        <p:nvSpPr>
+          <p:cNvPr id="4" name="TextBox 3"/>
           <p:cNvSpPr txBox="1"/>
           <p:nvPr/>
         </p:nvSpPr>
         <p:spPr>
           <a:xfrm>
-            <a:off x="777240" y="4937760"/>
-            <a:ext cx="10058400" cy="548640"/>
+            <a:off x="868680" y="4846320"/>
+            <a:ext cx="10424160" cy="457200"/>
           </a:xfrm>
           <a:prstGeom prst="rect">
             <a:avLst/>
@@ -3242,25 +3197,25 @@
             <a:r>
               <a:rPr sz="1500" b="1">
                 <a:solidFill>
-                  <a:srgbClr val="93C5FD"/>
+                  <a:srgbClr val="F59E0B"/>
                 </a:solidFill>
                 <a:latin typeface="Calibri"/>
               </a:rPr>
-              <a:t>LightGBM + Optuna   ·   Conformal prediction intervals   ·   SHAP explainability   ·   Streamlit</a:t>
-            </a:r>
-          </a:p>
-        </p:txBody>
-      </p:sp>
-      <p:sp>
-        <p:nvSpPr>
-          <p:cNvPr id="6" name="TextBox 5"/>
+              <a:t>LightGBM + Optuna · SHAP · conformal prediction intervals · Streamlit</a:t>
+            </a:r>
+          </a:p>
+        </p:txBody>
+      </p:sp>
+      <p:sp>
+        <p:nvSpPr>
+          <p:cNvPr id="5" name="TextBox 4"/>
           <p:cNvSpPr txBox="1"/>
           <p:nvPr/>
         </p:nvSpPr>
         <p:spPr>
           <a:xfrm>
-            <a:off x="777240" y="5943600"/>
-            <a:ext cx="10058400" cy="457200"/>
+            <a:off x="868680" y="5852160"/>
+            <a:ext cx="10424160" cy="457200"/>
           </a:xfrm>
           <a:prstGeom prst="rect">
             <a:avLst/>
@@ -3275,7 +3230,7 @@
           <a:p>
             <a:pPr algn="l"/>
             <a:r>
-              <a:rPr sz="1300" b="0">
+              <a:rPr sz="1200" b="0">
                 <a:solidFill>
                   <a:srgbClr val="64748B"/>
                 </a:solidFill>
@@ -3320,14 +3275,14 @@
         </p:nvSpPr>
         <p:spPr>
           <a:xfrm>
-            <a:off x="0" y="0"/>
-            <a:ext cx="12191695" cy="164592"/>
+            <a:off x="0" y="502920"/>
+            <a:ext cx="201168" cy="960120"/>
           </a:xfrm>
           <a:prstGeom prst="rect">
             <a:avLst/>
           </a:prstGeom>
           <a:solidFill>
-            <a:srgbClr val="2563EB"/>
+            <a:srgbClr val="F59E0B"/>
           </a:solidFill>
           <a:ln>
             <a:noFill/>
@@ -3363,8 +3318,8 @@
         </p:nvSpPr>
         <p:spPr>
           <a:xfrm>
-            <a:off x="548640" y="411480"/>
-            <a:ext cx="10972800" cy="914400"/>
+            <a:off x="502920" y="457200"/>
+            <a:ext cx="10972800" cy="365760"/>
           </a:xfrm>
           <a:prstGeom prst="rect">
             <a:avLst/>
@@ -3379,13 +3334,13 @@
           <a:p>
             <a:pPr algn="l"/>
             <a:r>
-              <a:rPr sz="3000" b="1">
-                <a:solidFill>
-                  <a:srgbClr val="1E3A8A"/>
+              <a:rPr sz="1300" b="1">
+                <a:solidFill>
+                  <a:srgbClr val="F59E0B"/>
                 </a:solidFill>
                 <a:latin typeface="Calibri"/>
               </a:rPr>
-              <a:t>The problem — valuation at scale</a:t>
+              <a:t>PROBLEM STATEMENT</a:t>
             </a:r>
           </a:p>
         </p:txBody>
@@ -3398,8 +3353,8 @@
         </p:nvSpPr>
         <p:spPr>
           <a:xfrm>
-            <a:off x="548640" y="1143000"/>
-            <a:ext cx="10972800" cy="548640"/>
+            <a:off x="502920" y="777240"/>
+            <a:ext cx="11155680" cy="914400"/>
           </a:xfrm>
           <a:prstGeom prst="rect">
             <a:avLst/>
@@ -3414,13 +3369,13 @@
           <a:p>
             <a:pPr algn="l"/>
             <a:r>
-              <a:rPr sz="1500" b="0">
-                <a:solidFill>
-                  <a:srgbClr val="64748B"/>
+              <a:rPr sz="2700" b="1">
+                <a:solidFill>
+                  <a:srgbClr val="1E3A8A"/>
                 </a:solidFill>
                 <a:latin typeface="Calibri"/>
               </a:rPr>
-              <a:t>Banks, insurers, iBuyers and marketplaces must value millions of homes instantly.</a:t>
+              <a:t>Value millions of homes, instantly</a:t>
             </a:r>
           </a:p>
         </p:txBody>
@@ -3433,8 +3388,8 @@
         </p:nvSpPr>
         <p:spPr>
           <a:xfrm>
-            <a:off x="640080" y="1737360"/>
-            <a:ext cx="10972800" cy="3657600"/>
+            <a:off x="640080" y="1783080"/>
+            <a:ext cx="10972800" cy="4023360"/>
           </a:xfrm>
           <a:prstGeom prst="rect">
             <a:avLst/>
@@ -3449,7 +3404,7 @@
           <a:p>
             <a:pPr>
               <a:spcAft>
-                <a:spcPts val="1400"/>
+                <a:spcPts val="1500"/>
               </a:spcAft>
             </a:pPr>
             <a:r>
@@ -3459,13 +3414,13 @@
                 </a:solidFill>
                 <a:latin typeface="Calibri"/>
               </a:rPr>
-              <a:t>•  An Automated Valuation Model (AVM) prices a property from its attributes — no human appraiser per home.</a:t>
+              <a:t>•  Banks, insurers, iBuyers and marketplaces need an instant price for every home — no human appraiser per property.</a:t>
             </a:r>
           </a:p>
           <a:p>
             <a:pPr>
               <a:spcAft>
-                <a:spcPts val="1400"/>
+                <a:spcPts val="1500"/>
               </a:spcAft>
             </a:pPr>
             <a:r>
@@ -3475,13 +3430,13 @@
                 </a:solidFill>
                 <a:latin typeface="Calibri"/>
               </a:rPr>
-              <a:t>•  Accurate across a huge range: this market spans $85k to $9M.</a:t>
+              <a:t>•  Accuracy must hold across a wide range (this market: $85k → $9M).</a:t>
             </a:r>
           </a:p>
           <a:p>
             <a:pPr>
               <a:spcAft>
-                <a:spcPts val="1400"/>
+                <a:spcPts val="1500"/>
               </a:spcAft>
             </a:pPr>
             <a:r>
@@ -3491,13 +3446,13 @@
                 </a:solidFill>
                 <a:latin typeface="Calibri"/>
               </a:rPr>
-              <a:t>•  Honest about uncertainty: a single number is unsafe for underwriting — decisions need a calibrated range.</a:t>
+              <a:t>•  A single number is unsafe for underwriting — decisions need a calibrated range.</a:t>
             </a:r>
           </a:p>
           <a:p>
             <a:pPr>
               <a:spcAft>
-                <a:spcPts val="1400"/>
+                <a:spcPts val="1500"/>
               </a:spcAft>
             </a:pPr>
             <a:r>
@@ -3507,211 +3462,7 @@
                 </a:solidFill>
                 <a:latin typeface="Calibri"/>
               </a:rPr>
-              <a:t>•  Explainable: regulators and customers must see WHY a home was valued as it was.</a:t>
-            </a:r>
-          </a:p>
-        </p:txBody>
-      </p:sp>
-      <p:sp>
-        <p:nvSpPr>
-          <p:cNvPr id="6" name="Rounded Rectangle 5"/>
-          <p:cNvSpPr/>
-          <p:nvPr/>
-        </p:nvSpPr>
-        <p:spPr>
-          <a:xfrm>
-            <a:off x="640080" y="5394960"/>
-            <a:ext cx="1060704" cy="384048"/>
-          </a:xfrm>
-          <a:prstGeom prst="roundRect">
-            <a:avLst/>
-          </a:prstGeom>
-          <a:solidFill>
-            <a:srgbClr val="DBEAFE"/>
-          </a:solidFill>
-          <a:ln>
-            <a:noFill/>
-          </a:ln>
-        </p:spPr>
-        <p:style>
-          <a:lnRef idx="1">
-            <a:schemeClr val="accent1"/>
-          </a:lnRef>
-          <a:fillRef idx="3">
-            <a:schemeClr val="accent1"/>
-          </a:fillRef>
-          <a:effectRef idx="2">
-            <a:schemeClr val="accent1"/>
-          </a:effectRef>
-          <a:fontRef idx="minor">
-            <a:schemeClr val="lt1"/>
-          </a:fontRef>
-        </p:style>
-        <p:txBody>
-          <a:bodyPr rtlCol="0" anchor="ctr" wrap="none"/>
-          <a:lstStyle/>
-          <a:p>
-            <a:pPr algn="ctr"/>
-            <a:r>
-              <a:rPr sz="1200" b="1">
-                <a:solidFill>
-                  <a:srgbClr val="1E3A8A"/>
-                </a:solidFill>
-              </a:rPr>
-              <a:t>Proptech</a:t>
-            </a:r>
-          </a:p>
-        </p:txBody>
-      </p:sp>
-      <p:sp>
-        <p:nvSpPr>
-          <p:cNvPr id="7" name="Rounded Rectangle 6"/>
-          <p:cNvSpPr/>
-          <p:nvPr/>
-        </p:nvSpPr>
-        <p:spPr>
-          <a:xfrm>
-            <a:off x="1865376" y="5394960"/>
-            <a:ext cx="1563624" cy="384048"/>
-          </a:xfrm>
-          <a:prstGeom prst="roundRect">
-            <a:avLst/>
-          </a:prstGeom>
-          <a:solidFill>
-            <a:srgbClr val="DBEAFE"/>
-          </a:solidFill>
-          <a:ln>
-            <a:noFill/>
-          </a:ln>
-        </p:spPr>
-        <p:style>
-          <a:lnRef idx="1">
-            <a:schemeClr val="accent1"/>
-          </a:lnRef>
-          <a:fillRef idx="3">
-            <a:schemeClr val="accent1"/>
-          </a:fillRef>
-          <a:effectRef idx="2">
-            <a:schemeClr val="accent1"/>
-          </a:effectRef>
-          <a:fontRef idx="minor">
-            <a:schemeClr val="lt1"/>
-          </a:fontRef>
-        </p:style>
-        <p:txBody>
-          <a:bodyPr rtlCol="0" anchor="ctr" wrap="none"/>
-          <a:lstStyle/>
-          <a:p>
-            <a:pPr algn="ctr"/>
-            <a:r>
-              <a:rPr sz="1200" b="1">
-                <a:solidFill>
-                  <a:srgbClr val="1E3A8A"/>
-                </a:solidFill>
-              </a:rPr>
-              <a:t>Mortgage risk</a:t>
-            </a:r>
-          </a:p>
-        </p:txBody>
-      </p:sp>
-      <p:sp>
-        <p:nvSpPr>
-          <p:cNvPr id="8" name="Rounded Rectangle 7"/>
-          <p:cNvSpPr/>
-          <p:nvPr/>
-        </p:nvSpPr>
-        <p:spPr>
-          <a:xfrm>
-            <a:off x="3593591" y="5394960"/>
-            <a:ext cx="960120" cy="384048"/>
-          </a:xfrm>
-          <a:prstGeom prst="roundRect">
-            <a:avLst/>
-          </a:prstGeom>
-          <a:solidFill>
-            <a:srgbClr val="DBEAFE"/>
-          </a:solidFill>
-          <a:ln>
-            <a:noFill/>
-          </a:ln>
-        </p:spPr>
-        <p:style>
-          <a:lnRef idx="1">
-            <a:schemeClr val="accent1"/>
-          </a:lnRef>
-          <a:fillRef idx="3">
-            <a:schemeClr val="accent1"/>
-          </a:fillRef>
-          <a:effectRef idx="2">
-            <a:schemeClr val="accent1"/>
-          </a:effectRef>
-          <a:fontRef idx="minor">
-            <a:schemeClr val="lt1"/>
-          </a:fontRef>
-        </p:style>
-        <p:txBody>
-          <a:bodyPr rtlCol="0" anchor="ctr" wrap="none"/>
-          <a:lstStyle/>
-          <a:p>
-            <a:pPr algn="ctr"/>
-            <a:r>
-              <a:rPr sz="1200" b="1">
-                <a:solidFill>
-                  <a:srgbClr val="1E3A8A"/>
-                </a:solidFill>
-              </a:rPr>
-              <a:t>iBuying</a:t>
-            </a:r>
-          </a:p>
-        </p:txBody>
-      </p:sp>
-      <p:sp>
-        <p:nvSpPr>
-          <p:cNvPr id="9" name="Rounded Rectangle 8"/>
-          <p:cNvSpPr/>
-          <p:nvPr/>
-        </p:nvSpPr>
-        <p:spPr>
-          <a:xfrm>
-            <a:off x="4718304" y="5394960"/>
-            <a:ext cx="1161288" cy="384048"/>
-          </a:xfrm>
-          <a:prstGeom prst="roundRect">
-            <a:avLst/>
-          </a:prstGeom>
-          <a:solidFill>
-            <a:srgbClr val="DBEAFE"/>
-          </a:solidFill>
-          <a:ln>
-            <a:noFill/>
-          </a:ln>
-        </p:spPr>
-        <p:style>
-          <a:lnRef idx="1">
-            <a:schemeClr val="accent1"/>
-          </a:lnRef>
-          <a:fillRef idx="3">
-            <a:schemeClr val="accent1"/>
-          </a:fillRef>
-          <a:effectRef idx="2">
-            <a:schemeClr val="accent1"/>
-          </a:effectRef>
-          <a:fontRef idx="minor">
-            <a:schemeClr val="lt1"/>
-          </a:fontRef>
-        </p:style>
-        <p:txBody>
-          <a:bodyPr rtlCol="0" anchor="ctr" wrap="none"/>
-          <a:lstStyle/>
-          <a:p>
-            <a:pPr algn="ctr"/>
-            <a:r>
-              <a:rPr sz="1200" b="1">
-                <a:solidFill>
-                  <a:srgbClr val="1E3A8A"/>
-                </a:solidFill>
-              </a:rPr>
-              <a:t>Insurance</a:t>
+              <a:t>•  Regulators and customers require knowing WHY a home was valued as it was.</a:t>
             </a:r>
           </a:p>
         </p:txBody>
@@ -3750,14 +3501,14 @@
         </p:nvSpPr>
         <p:spPr>
           <a:xfrm>
-            <a:off x="0" y="0"/>
-            <a:ext cx="12191695" cy="164592"/>
+            <a:off x="0" y="502920"/>
+            <a:ext cx="201168" cy="960120"/>
           </a:xfrm>
           <a:prstGeom prst="rect">
             <a:avLst/>
           </a:prstGeom>
           <a:solidFill>
-            <a:srgbClr val="2563EB"/>
+            <a:srgbClr val="F59E0B"/>
           </a:solidFill>
           <a:ln>
             <a:noFill/>
@@ -3793,8 +3544,8 @@
         </p:nvSpPr>
         <p:spPr>
           <a:xfrm>
-            <a:off x="548640" y="411480"/>
-            <a:ext cx="10972800" cy="914400"/>
+            <a:off x="502920" y="457200"/>
+            <a:ext cx="10972800" cy="365760"/>
           </a:xfrm>
           <a:prstGeom prst="rect">
             <a:avLst/>
@@ -3809,13 +3560,13 @@
           <a:p>
             <a:pPr algn="l"/>
             <a:r>
-              <a:rPr sz="3000" b="1">
-                <a:solidFill>
-                  <a:srgbClr val="1E3A8A"/>
+              <a:rPr sz="1300" b="1">
+                <a:solidFill>
+                  <a:srgbClr val="F59E0B"/>
                 </a:solidFill>
                 <a:latin typeface="Calibri"/>
               </a:rPr>
-              <a:t>The data — and why it's hard</a:t>
+              <a:t>APPROACH · LOGIC · TECH STACK</a:t>
             </a:r>
           </a:p>
         </p:txBody>
@@ -3828,8 +3579,8 @@
         </p:nvSpPr>
         <p:spPr>
           <a:xfrm>
-            <a:off x="548640" y="1143000"/>
-            <a:ext cx="10972800" cy="548640"/>
+            <a:off x="502920" y="777240"/>
+            <a:ext cx="11155680" cy="914400"/>
           </a:xfrm>
           <a:prstGeom prst="rect">
             <a:avLst/>
@@ -3844,13 +3595,13 @@
           <a:p>
             <a:pPr algn="l"/>
             <a:r>
-              <a:rPr sz="1500" b="0">
-                <a:solidFill>
-                  <a:srgbClr val="64748B"/>
+              <a:rPr sz="2700" b="1">
+                <a:solidFill>
+                  <a:srgbClr val="1E3A8A"/>
                 </a:solidFill>
                 <a:latin typeface="Calibri"/>
               </a:rPr>
-              <a:t>Melbourne housing: 13,580 sales × 21 fields. Exactly as messy as real estate data.</a:t>
+              <a:t>One pipeline: raw row → $ + interval + why</a:t>
             </a:r>
           </a:p>
         </p:txBody>
@@ -3863,8 +3614,8 @@
         </p:nvSpPr>
         <p:spPr>
           <a:xfrm>
-            <a:off x="640080" y="1737360"/>
-            <a:ext cx="5394960" cy="4206240"/>
+            <a:off x="640080" y="1783080"/>
+            <a:ext cx="6766560" cy="4206240"/>
           </a:xfrm>
           <a:prstGeom prst="rect">
             <a:avLst/>
@@ -3879,109 +3630,255 @@
           <a:p>
             <a:pPr>
               <a:spcAft>
-                <a:spcPts val="1200"/>
+                <a:spcPts val="900"/>
               </a:spcAft>
             </a:pPr>
             <a:r>
-              <a:rPr sz="1600">
+              <a:rPr sz="1400">
                 <a:solidFill>
                   <a:srgbClr val="0F172A"/>
                 </a:solidFill>
                 <a:latin typeface="Calibri"/>
               </a:rPr>
-              <a:t>•  BuildingArea 47% missing, YearBuilt 40%, CouncilArea 10%.</a:t>
+              <a:t>•  Model log(price) — proportional error for a skewed, multiplicative quantity.</a:t>
             </a:r>
           </a:p>
           <a:p>
             <a:pPr>
               <a:spcAft>
-                <a:spcPts val="1200"/>
+                <a:spcPts val="900"/>
               </a:spcAft>
             </a:pPr>
             <a:r>
-              <a:rPr sz="1600">
+              <a:rPr sz="1400">
                 <a:solidFill>
                   <a:srgbClr val="0F172A"/>
                 </a:solidFill>
                 <a:latin typeface="Calibri"/>
               </a:rPr>
-              <a:t>•  Right-skewed target across two orders of magnitude.</a:t>
+              <a:t>•  Median impute + missingness flags (a missing BuildingArea usually means a unit).</a:t>
             </a:r>
           </a:p>
           <a:p>
             <a:pPr>
               <a:spcAft>
-                <a:spcPts val="1200"/>
+                <a:spcPts val="900"/>
               </a:spcAft>
             </a:pPr>
             <a:r>
-              <a:rPr sz="1600">
+              <a:rPr sz="1400">
                 <a:solidFill>
                   <a:srgbClr val="0F172A"/>
                 </a:solidFill>
                 <a:latin typeface="Calibri"/>
               </a:rPr>
-              <a:t>•  314 suburbs &amp; 200+ postcodes — strongest signal, but a leakage trap.</a:t>
+              <a:t>•  One-hot for type/method/region; cross-fitted TargetEncoder for suburb/postcode (no leakage).</a:t>
             </a:r>
           </a:p>
           <a:p>
             <a:pPr>
               <a:spcAft>
-                <a:spcPts val="1200"/>
+                <a:spcPts val="900"/>
               </a:spcAft>
             </a:pPr>
             <a:r>
-              <a:rPr sz="1600">
+              <a:rPr sz="1400">
                 <a:solidFill>
                   <a:srgbClr val="0F172A"/>
                 </a:solidFill>
                 <a:latin typeface="Calibri"/>
               </a:rPr>
-              <a:t>•  Outliers &amp; data-entry errors: 0 m² land, impossible build years.</a:t>
+              <a:t>•  LightGBM won a 5-model zoo (vs XGBoost, CatBoost, RandomForest, Ridge).</a:t>
             </a:r>
           </a:p>
           <a:p>
             <a:pPr>
               <a:spcAft>
-                <a:spcPts val="1200"/>
+                <a:spcPts val="900"/>
               </a:spcAft>
             </a:pPr>
             <a:r>
-              <a:rPr sz="1600">
+              <a:rPr sz="1400">
                 <a:solidFill>
                   <a:srgbClr val="0F172A"/>
                 </a:solidFill>
                 <a:latin typeface="Calibri"/>
               </a:rPr>
-              <a:t>•  Must serve predictions from RAW inputs, not pre-baked arrays.</a:t>
-            </a:r>
-          </a:p>
-        </p:txBody>
-      </p:sp>
-      <p:pic>
-        <p:nvPicPr>
-          <p:cNvPr id="6" name="Picture 5" descr="error_by_price.png"/>
-          <p:cNvPicPr>
-            <a:picLocks noChangeAspect="1"/>
-          </p:cNvPicPr>
+              <a:t>•  Optuna TPE tuning over 8 hyperparameters; held-out test evaluation.</a:t>
+            </a:r>
+          </a:p>
+          <a:p>
+            <a:pPr>
+              <a:spcAft>
+                <a:spcPts val="900"/>
+              </a:spcAft>
+            </a:pPr>
+            <a:r>
+              <a:rPr sz="1400">
+                <a:solidFill>
+                  <a:srgbClr val="0F172A"/>
+                </a:solidFill>
+                <a:latin typeface="Calibri"/>
+              </a:rPr>
+              <a:t>•  Split-conformal prediction intervals + SHAP explanations.</a:t>
+            </a:r>
+          </a:p>
+        </p:txBody>
+      </p:sp>
+      <p:sp>
+        <p:nvSpPr>
+          <p:cNvPr id="6" name="TextBox 5"/>
+          <p:cNvSpPr txBox="1"/>
           <p:nvPr/>
-        </p:nvPicPr>
-        <p:blipFill>
-          <a:blip r:embed="rId2"/>
-          <a:stretch>
-            <a:fillRect/>
-          </a:stretch>
-        </p:blipFill>
-        <p:spPr>
-          <a:xfrm>
-            <a:off x="6309360" y="2011680"/>
-            <a:ext cx="5394960" cy="3197236"/>
+        </p:nvSpPr>
+        <p:spPr>
+          <a:xfrm>
+            <a:off x="7680960" y="1828800"/>
+            <a:ext cx="4023360" cy="365760"/>
           </a:xfrm>
           <a:prstGeom prst="rect">
             <a:avLst/>
           </a:prstGeom>
-        </p:spPr>
-      </p:pic>
+          <a:noFill/>
+        </p:spPr>
+        <p:txBody>
+          <a:bodyPr wrap="square" anchor="t">
+            <a:spAutoFit/>
+          </a:bodyPr>
+          <a:lstStyle/>
+          <a:p>
+            <a:pPr algn="l"/>
+            <a:r>
+              <a:rPr sz="1200" b="1">
+                <a:solidFill>
+                  <a:srgbClr val="F59E0B"/>
+                </a:solidFill>
+                <a:latin typeface="Calibri"/>
+              </a:rPr>
+              <a:t>TECH STACK</a:t>
+            </a:r>
+          </a:p>
+        </p:txBody>
+      </p:sp>
+      <p:sp>
+        <p:nvSpPr>
+          <p:cNvPr id="7" name="TextBox 6"/>
+          <p:cNvSpPr txBox="1"/>
+          <p:nvPr/>
+        </p:nvSpPr>
+        <p:spPr>
+          <a:xfrm>
+            <a:off x="7680960" y="2194560"/>
+            <a:ext cx="4114800" cy="3657600"/>
+          </a:xfrm>
+          <a:prstGeom prst="rect">
+            <a:avLst/>
+          </a:prstGeom>
+          <a:noFill/>
+        </p:spPr>
+        <p:txBody>
+          <a:bodyPr wrap="square">
+            <a:spAutoFit/>
+          </a:bodyPr>
+          <a:lstStyle/>
+          <a:p>
+            <a:pPr>
+              <a:spcAft>
+                <a:spcPts val="900"/>
+              </a:spcAft>
+            </a:pPr>
+            <a:r>
+              <a:rPr sz="1400">
+                <a:solidFill>
+                  <a:srgbClr val="0F172A"/>
+                </a:solidFill>
+                <a:latin typeface="Calibri"/>
+              </a:rPr>
+              <a:t>•  Python · pandas · NumPy</a:t>
+            </a:r>
+          </a:p>
+          <a:p>
+            <a:pPr>
+              <a:spcAft>
+                <a:spcPts val="900"/>
+              </a:spcAft>
+            </a:pPr>
+            <a:r>
+              <a:rPr sz="1400">
+                <a:solidFill>
+                  <a:srgbClr val="0F172A"/>
+                </a:solidFill>
+                <a:latin typeface="Calibri"/>
+              </a:rPr>
+              <a:t>•  scikit-learn pipelines</a:t>
+            </a:r>
+          </a:p>
+          <a:p>
+            <a:pPr>
+              <a:spcAft>
+                <a:spcPts val="900"/>
+              </a:spcAft>
+            </a:pPr>
+            <a:r>
+              <a:rPr sz="1400">
+                <a:solidFill>
+                  <a:srgbClr val="0F172A"/>
+                </a:solidFill>
+                <a:latin typeface="Calibri"/>
+              </a:rPr>
+              <a:t>•  LightGBM / XGBoost / CatBoost</a:t>
+            </a:r>
+          </a:p>
+          <a:p>
+            <a:pPr>
+              <a:spcAft>
+                <a:spcPts val="900"/>
+              </a:spcAft>
+            </a:pPr>
+            <a:r>
+              <a:rPr sz="1400">
+                <a:solidFill>
+                  <a:srgbClr val="0F172A"/>
+                </a:solidFill>
+                <a:latin typeface="Calibri"/>
+              </a:rPr>
+              <a:t>•  Optuna</a:t>
+            </a:r>
+          </a:p>
+          <a:p>
+            <a:pPr>
+              <a:spcAft>
+                <a:spcPts val="900"/>
+              </a:spcAft>
+            </a:pPr>
+            <a:r>
+              <a:rPr sz="1400">
+                <a:solidFill>
+                  <a:srgbClr val="0F172A"/>
+                </a:solidFill>
+                <a:latin typeface="Calibri"/>
+              </a:rPr>
+              <a:t>•  SHAP</a:t>
+            </a:r>
+          </a:p>
+          <a:p>
+            <a:pPr>
+              <a:spcAft>
+                <a:spcPts val="900"/>
+              </a:spcAft>
+            </a:pPr>
+            <a:r>
+              <a:rPr sz="1400">
+                <a:solidFill>
+                  <a:srgbClr val="0F172A"/>
+                </a:solidFill>
+                <a:latin typeface="Calibri"/>
+              </a:rPr>
+              <a:t>•  Streamlit · Plotly</a:t>
+            </a:r>
+          </a:p>
+        </p:txBody>
+      </p:sp>
     </p:spTree>
   </p:cSld>
   <p:clrMapOvr>
@@ -4016,14 +3913,14 @@
         </p:nvSpPr>
         <p:spPr>
           <a:xfrm>
-            <a:off x="0" y="0"/>
-            <a:ext cx="12191695" cy="164592"/>
+            <a:off x="0" y="502920"/>
+            <a:ext cx="201168" cy="960120"/>
           </a:xfrm>
           <a:prstGeom prst="rect">
             <a:avLst/>
           </a:prstGeom>
           <a:solidFill>
-            <a:srgbClr val="2563EB"/>
+            <a:srgbClr val="F59E0B"/>
           </a:solidFill>
           <a:ln>
             <a:noFill/>
@@ -4059,8 +3956,8 @@
         </p:nvSpPr>
         <p:spPr>
           <a:xfrm>
-            <a:off x="548640" y="411480"/>
-            <a:ext cx="10972800" cy="914400"/>
+            <a:off x="502920" y="457200"/>
+            <a:ext cx="10972800" cy="365760"/>
           </a:xfrm>
           <a:prstGeom prst="rect">
             <a:avLst/>
@@ -4075,13 +3972,13 @@
           <a:p>
             <a:pPr algn="l"/>
             <a:r>
-              <a:rPr sz="3000" b="1">
-                <a:solidFill>
-                  <a:srgbClr val="1E3A8A"/>
+              <a:rPr sz="1300" b="1">
+                <a:solidFill>
+                  <a:srgbClr val="F59E0B"/>
                 </a:solidFill>
                 <a:latin typeface="Calibri"/>
               </a:rPr>
-              <a:t>Approach &amp; tech-stack logic</a:t>
+              <a:t>KEY FINDINGS</a:t>
             </a:r>
           </a:p>
         </p:txBody>
@@ -4094,8 +3991,8 @@
         </p:nvSpPr>
         <p:spPr>
           <a:xfrm>
-            <a:off x="548640" y="1143000"/>
-            <a:ext cx="10972800" cy="548640"/>
+            <a:off x="502920" y="777240"/>
+            <a:ext cx="11155680" cy="914400"/>
           </a:xfrm>
           <a:prstGeom prst="rect">
             <a:avLst/>
@@ -4110,13 +4007,13 @@
           <a:p>
             <a:pPr algn="l"/>
             <a:r>
-              <a:rPr sz="1500" b="0">
-                <a:solidFill>
-                  <a:srgbClr val="64748B"/>
+              <a:rPr sz="2700" b="1">
+                <a:solidFill>
+                  <a:srgbClr val="1E3A8A"/>
                 </a:solidFill>
                 <a:latin typeface="Calibri"/>
               </a:rPr>
-              <a:t>One scikit-learn pipeline: raw property row → dollars + interval + explanation.</a:t>
+              <a:t>What drives a valuation</a:t>
             </a:r>
           </a:p>
         </p:txBody>
@@ -4129,8 +4026,8 @@
         </p:nvSpPr>
         <p:spPr>
           <a:xfrm>
-            <a:off x="640080" y="1645920"/>
-            <a:ext cx="10972800" cy="548640"/>
+            <a:off x="640080" y="1737360"/>
+            <a:ext cx="5212080" cy="4114800"/>
           </a:xfrm>
           <a:prstGeom prst="rect">
             <a:avLst/>
@@ -4138,143 +4035,116 @@
           <a:noFill/>
         </p:spPr>
         <p:txBody>
-          <a:bodyPr wrap="square" anchor="t">
+          <a:bodyPr wrap="square">
             <a:spAutoFit/>
           </a:bodyPr>
           <a:lstStyle/>
           <a:p>
-            <a:pPr algn="l"/>
-            <a:r>
-              <a:rPr sz="1500" b="1">
-                <a:solidFill>
-                  <a:srgbClr val="2563EB"/>
+            <a:pPr>
+              <a:spcAft>
+                <a:spcPts val="1100"/>
+              </a:spcAft>
+            </a:pPr>
+            <a:r>
+              <a:rPr sz="1500">
+                <a:solidFill>
+                  <a:srgbClr val="0F172A"/>
                 </a:solidFill>
                 <a:latin typeface="Calibri"/>
               </a:rPr>
-              <a:t>raw row → ColumnTransformer → LightGBM (log-target) → TransformedTargetRegressor → $  +  interval  +  SHAP</a:t>
-            </a:r>
-          </a:p>
-        </p:txBody>
-      </p:sp>
-      <p:sp>
-        <p:nvSpPr>
-          <p:cNvPr id="6" name="TextBox 5"/>
-          <p:cNvSpPr txBox="1"/>
+              <a:t>•  Property type (house vs unit) and distance to the CBD dominate.</a:t>
+            </a:r>
+          </a:p>
+          <a:p>
+            <a:pPr>
+              <a:spcAft>
+                <a:spcPts val="1100"/>
+              </a:spcAft>
+            </a:pPr>
+            <a:r>
+              <a:rPr sz="1500">
+                <a:solidFill>
+                  <a:srgbClr val="0F172A"/>
+                </a:solidFill>
+                <a:latin typeface="Calibri"/>
+              </a:rPr>
+              <a:t>•  Postcode &amp; suburb encode fine-grained location value.</a:t>
+            </a:r>
+          </a:p>
+          <a:p>
+            <a:pPr>
+              <a:spcAft>
+                <a:spcPts val="1100"/>
+              </a:spcAft>
+            </a:pPr>
+            <a:r>
+              <a:rPr sz="1500">
+                <a:solidFill>
+                  <a:srgbClr val="0F172A"/>
+                </a:solidFill>
+                <a:latin typeface="Calibri"/>
+              </a:rPr>
+              <a:t>•  Land size and bathrooms add property-level detail.</a:t>
+            </a:r>
+          </a:p>
+          <a:p>
+            <a:pPr>
+              <a:spcAft>
+                <a:spcPts val="1100"/>
+              </a:spcAft>
+            </a:pPr>
+            <a:r>
+              <a:rPr sz="1500">
+                <a:solidFill>
+                  <a:srgbClr val="0F172A"/>
+                </a:solidFill>
+                <a:latin typeface="Calibri"/>
+              </a:rPr>
+              <a:t>•  Missingness is itself signal — flagged, not dropped.</a:t>
+            </a:r>
+          </a:p>
+          <a:p>
+            <a:pPr>
+              <a:spcAft>
+                <a:spcPts val="1100"/>
+              </a:spcAft>
+            </a:pPr>
+            <a:r>
+              <a:rPr sz="1500">
+                <a:solidFill>
+                  <a:srgbClr val="0F172A"/>
+                </a:solidFill>
+                <a:latin typeface="Calibri"/>
+              </a:rPr>
+              <a:t>•  Per-prediction SHAP shows each factor as a ± % effect on that home.</a:t>
+            </a:r>
+          </a:p>
+        </p:txBody>
+      </p:sp>
+      <p:pic>
+        <p:nvPicPr>
+          <p:cNvPr id="6" name="Picture 5" descr="shap_importance.png"/>
+          <p:cNvPicPr>
+            <a:picLocks noChangeAspect="1"/>
+          </p:cNvPicPr>
           <p:nvPr/>
-        </p:nvSpPr>
-        <p:spPr>
-          <a:xfrm>
-            <a:off x="640080" y="2377440"/>
-            <a:ext cx="10972800" cy="3657600"/>
+        </p:nvPicPr>
+        <p:blipFill>
+          <a:blip r:embed="rId2"/>
+          <a:stretch>
+            <a:fillRect/>
+          </a:stretch>
+        </p:blipFill>
+        <p:spPr>
+          <a:xfrm>
+            <a:off x="6126480" y="1737360"/>
+            <a:ext cx="4784565" cy="4480560"/>
           </a:xfrm>
           <a:prstGeom prst="rect">
             <a:avLst/>
           </a:prstGeom>
-          <a:noFill/>
-        </p:spPr>
-        <p:txBody>
-          <a:bodyPr wrap="square">
-            <a:spAutoFit/>
-          </a:bodyPr>
-          <a:lstStyle/>
-          <a:p>
-            <a:pPr>
-              <a:spcAft>
-                <a:spcPts val="1000"/>
-              </a:spcAft>
-            </a:pPr>
-            <a:r>
-              <a:rPr sz="1500">
-                <a:solidFill>
-                  <a:srgbClr val="0F172A"/>
-                </a:solidFill>
-                <a:latin typeface="Calibri"/>
-              </a:rPr>
-              <a:t>•  log1p(Price) target — proportional error for a skewed, multiplicative quantity.</a:t>
-            </a:r>
-          </a:p>
-          <a:p>
-            <a:pPr>
-              <a:spcAft>
-                <a:spcPts val="1000"/>
-              </a:spcAft>
-            </a:pPr>
-            <a:r>
-              <a:rPr sz="1500">
-                <a:solidFill>
-                  <a:srgbClr val="0F172A"/>
-                </a:solidFill>
-                <a:latin typeface="Calibri"/>
-              </a:rPr>
-              <a:t>•  Median impute + explicit missingness flags (a missing BuildingArea usually means a unit).</a:t>
-            </a:r>
-          </a:p>
-          <a:p>
-            <a:pPr>
-              <a:spcAft>
-                <a:spcPts val="1000"/>
-              </a:spcAft>
-            </a:pPr>
-            <a:r>
-              <a:rPr sz="1500">
-                <a:solidFill>
-                  <a:srgbClr val="0F172A"/>
-                </a:solidFill>
-                <a:latin typeface="Calibri"/>
-              </a:rPr>
-              <a:t>•  One-hot for Type/Method/Region; cross-fitted TargetEncoder for Suburb/Postcode/Council (no leakage).</a:t>
-            </a:r>
-          </a:p>
-          <a:p>
-            <a:pPr>
-              <a:spcAft>
-                <a:spcPts val="1000"/>
-              </a:spcAft>
-            </a:pPr>
-            <a:r>
-              <a:rPr sz="1500">
-                <a:solidFill>
-                  <a:srgbClr val="0F172A"/>
-                </a:solidFill>
-                <a:latin typeface="Calibri"/>
-              </a:rPr>
-              <a:t>•  LightGBM won a 5-model zoo (vs XGBoost, CatBoost, RandomForest, Ridge).</a:t>
-            </a:r>
-          </a:p>
-          <a:p>
-            <a:pPr>
-              <a:spcAft>
-                <a:spcPts val="1000"/>
-              </a:spcAft>
-            </a:pPr>
-            <a:r>
-              <a:rPr sz="1500">
-                <a:solidFill>
-                  <a:srgbClr val="0F172A"/>
-                </a:solidFill>
-                <a:latin typeface="Calibri"/>
-              </a:rPr>
-              <a:t>•  Optuna TPE search — 40 trials over 8 hyperparameters, optimising CV MAE.</a:t>
-            </a:r>
-          </a:p>
-          <a:p>
-            <a:pPr>
-              <a:spcAft>
-                <a:spcPts val="1000"/>
-              </a:spcAft>
-            </a:pPr>
-            <a:r>
-              <a:rPr sz="1500">
-                <a:solidFill>
-                  <a:srgbClr val="0F172A"/>
-                </a:solidFill>
-                <a:latin typeface="Calibri"/>
-              </a:rPr>
-              <a:t>•  Split-conformal intervals for distribution-free, verified-coverage uncertainty.</a:t>
-            </a:r>
-          </a:p>
-        </p:txBody>
-      </p:sp>
+        </p:spPr>
+      </p:pic>
     </p:spTree>
   </p:cSld>
   <p:clrMapOvr>
@@ -4309,14 +4179,14 @@
         </p:nvSpPr>
         <p:spPr>
           <a:xfrm>
-            <a:off x="0" y="0"/>
-            <a:ext cx="12191695" cy="164592"/>
+            <a:off x="0" y="502920"/>
+            <a:ext cx="201168" cy="960120"/>
           </a:xfrm>
           <a:prstGeom prst="rect">
             <a:avLst/>
           </a:prstGeom>
           <a:solidFill>
-            <a:srgbClr val="2563EB"/>
+            <a:srgbClr val="F59E0B"/>
           </a:solidFill>
           <a:ln>
             <a:noFill/>
@@ -4352,8 +4222,8 @@
         </p:nvSpPr>
         <p:spPr>
           <a:xfrm>
-            <a:off x="548640" y="411480"/>
-            <a:ext cx="10972800" cy="914400"/>
+            <a:off x="502920" y="457200"/>
+            <a:ext cx="10972800" cy="365760"/>
           </a:xfrm>
           <a:prstGeom prst="rect">
             <a:avLst/>
@@ -4368,13 +4238,13 @@
           <a:p>
             <a:pPr algn="l"/>
             <a:r>
-              <a:rPr sz="3000" b="1">
-                <a:solidFill>
-                  <a:srgbClr val="1E3A8A"/>
+              <a:rPr sz="1300" b="1">
+                <a:solidFill>
+                  <a:srgbClr val="F59E0B"/>
                 </a:solidFill>
                 <a:latin typeface="Calibri"/>
               </a:rPr>
-              <a:t>How each challenge was tackled</a:t>
+              <a:t>MODEL PERFORMANCE</a:t>
             </a:r>
           </a:p>
         </p:txBody>
@@ -4387,8 +4257,8 @@
         </p:nvSpPr>
         <p:spPr>
           <a:xfrm>
-            <a:off x="640080" y="1737360"/>
-            <a:ext cx="10972800" cy="4206240"/>
+            <a:off x="502920" y="777240"/>
+            <a:ext cx="11155680" cy="914400"/>
           </a:xfrm>
           <a:prstGeom prst="rect">
             <a:avLst/>
@@ -4396,108 +4266,368 @@
           <a:noFill/>
         </p:spPr>
         <p:txBody>
-          <a:bodyPr wrap="square">
+          <a:bodyPr wrap="square" anchor="t">
             <a:spAutoFit/>
           </a:bodyPr>
           <a:lstStyle/>
           <a:p>
-            <a:pPr>
-              <a:spcAft>
-                <a:spcPts val="1400"/>
-              </a:spcAft>
-            </a:pPr>
-            <a:r>
-              <a:rPr sz="1700">
-                <a:solidFill>
-                  <a:srgbClr val="0F172A"/>
+            <a:pPr algn="l"/>
+            <a:r>
+              <a:rPr sz="2700" b="1">
+                <a:solidFill>
+                  <a:srgbClr val="1E3A8A"/>
                 </a:solidFill>
                 <a:latin typeface="Calibri"/>
               </a:rPr>
-              <a:t>•  Missingness → median impute + *_missing indicators (turn a gap into signal).</a:t>
-            </a:r>
-          </a:p>
-          <a:p>
-            <a:pPr>
-              <a:spcAft>
-                <a:spcPts val="1400"/>
-              </a:spcAft>
-            </a:pPr>
-            <a:r>
-              <a:rPr sz="1700">
-                <a:solidFill>
-                  <a:srgbClr val="0F172A"/>
-                </a:solidFill>
-                <a:latin typeface="Calibri"/>
+              <a:t>Held-out test set</a:t>
+            </a:r>
+          </a:p>
+        </p:txBody>
+      </p:sp>
+      <p:sp>
+        <p:nvSpPr>
+          <p:cNvPr id="5" name="Rounded Rectangle 4"/>
+          <p:cNvSpPr/>
+          <p:nvPr/>
+        </p:nvSpPr>
+        <p:spPr>
+          <a:xfrm>
+            <a:off x="640080" y="1828800"/>
+            <a:ext cx="2103120" cy="1280160"/>
+          </a:xfrm>
+          <a:prstGeom prst="roundRect">
+            <a:avLst/>
+          </a:prstGeom>
+          <a:solidFill>
+            <a:srgbClr val="FBF7EE"/>
+          </a:solidFill>
+          <a:ln>
+            <a:solidFill>
+              <a:srgbClr val="E2E8F0"/>
+            </a:solidFill>
+          </a:ln>
+        </p:spPr>
+        <p:style>
+          <a:lnRef idx="1">
+            <a:schemeClr val="accent1"/>
+          </a:lnRef>
+          <a:fillRef idx="3">
+            <a:schemeClr val="accent1"/>
+          </a:fillRef>
+          <a:effectRef idx="2">
+            <a:schemeClr val="accent1"/>
+          </a:effectRef>
+          <a:fontRef idx="minor">
+            <a:schemeClr val="lt1"/>
+          </a:fontRef>
+        </p:style>
+        <p:txBody>
+          <a:bodyPr rtlCol="0" anchor="ctr" wrap="square"/>
+          <a:lstStyle/>
+          <a:p>
+            <a:pPr algn="ctr"/>
+            <a:r>
+              <a:rPr sz="1200">
+                <a:solidFill>
+                  <a:srgbClr val="64748B"/>
+                </a:solidFill>
               </a:rPr>
-              <a:t>•  Skew → log-target modelling; report both dollar and percentage error.</a:t>
-            </a:r>
-          </a:p>
-          <a:p>
-            <a:pPr>
-              <a:spcAft>
-                <a:spcPts val="1400"/>
-              </a:spcAft>
-            </a:pPr>
-            <a:r>
-              <a:rPr sz="1700">
-                <a:solidFill>
-                  <a:srgbClr val="0F172A"/>
-                </a:solidFill>
-                <a:latin typeface="Calibri"/>
+              <a:t>R²</a:t>
+            </a:r>
+          </a:p>
+          <a:p>
+            <a:pPr algn="ctr"/>
+            <a:r>
+              <a:rPr sz="2300" b="1">
+                <a:solidFill>
+                  <a:srgbClr val="1E3A8A"/>
+                </a:solidFill>
               </a:rPr>
-              <a:t>•  Location leakage → TargetEncoder cross-fitting; all encoding lives inside the CV pipeline.</a:t>
-            </a:r>
-          </a:p>
-          <a:p>
-            <a:pPr>
-              <a:spcAft>
-                <a:spcPts val="1400"/>
-              </a:spcAft>
-            </a:pPr>
-            <a:r>
-              <a:rPr sz="1700">
-                <a:solidFill>
-                  <a:srgbClr val="0F172A"/>
-                </a:solidFill>
-                <a:latin typeface="Calibri"/>
+              <a:t>0.848</a:t>
+            </a:r>
+          </a:p>
+        </p:txBody>
+      </p:sp>
+      <p:sp>
+        <p:nvSpPr>
+          <p:cNvPr id="6" name="Rounded Rectangle 5"/>
+          <p:cNvSpPr/>
+          <p:nvPr/>
+        </p:nvSpPr>
+        <p:spPr>
+          <a:xfrm>
+            <a:off x="2907791" y="1828800"/>
+            <a:ext cx="2103120" cy="1280160"/>
+          </a:xfrm>
+          <a:prstGeom prst="roundRect">
+            <a:avLst/>
+          </a:prstGeom>
+          <a:solidFill>
+            <a:srgbClr val="FBF7EE"/>
+          </a:solidFill>
+          <a:ln>
+            <a:solidFill>
+              <a:srgbClr val="E2E8F0"/>
+            </a:solidFill>
+          </a:ln>
+        </p:spPr>
+        <p:style>
+          <a:lnRef idx="1">
+            <a:schemeClr val="accent1"/>
+          </a:lnRef>
+          <a:fillRef idx="3">
+            <a:schemeClr val="accent1"/>
+          </a:fillRef>
+          <a:effectRef idx="2">
+            <a:schemeClr val="accent1"/>
+          </a:effectRef>
+          <a:fontRef idx="minor">
+            <a:schemeClr val="lt1"/>
+          </a:fontRef>
+        </p:style>
+        <p:txBody>
+          <a:bodyPr rtlCol="0" anchor="ctr" wrap="square"/>
+          <a:lstStyle/>
+          <a:p>
+            <a:pPr algn="ctr"/>
+            <a:r>
+              <a:rPr sz="1200">
+                <a:solidFill>
+                  <a:srgbClr val="64748B"/>
+                </a:solidFill>
               </a:rPr>
-              <a:t>•  Outliers → 0-values treated as missing; land/building capped at the 99.5th percentile.</a:t>
-            </a:r>
-          </a:p>
-          <a:p>
-            <a:pPr>
-              <a:spcAft>
-                <a:spcPts val="1400"/>
-              </a:spcAft>
-            </a:pPr>
-            <a:r>
-              <a:rPr sz="1700">
-                <a:solidFill>
-                  <a:srgbClr val="0F172A"/>
-                </a:solidFill>
-                <a:latin typeface="Calibri"/>
+              <a:t>MAPE</a:t>
+            </a:r>
+          </a:p>
+          <a:p>
+            <a:pPr algn="ctr"/>
+            <a:r>
+              <a:rPr sz="2300" b="1">
+                <a:solidFill>
+                  <a:srgbClr val="1E3A8A"/>
+                </a:solidFill>
               </a:rPr>
-              <a:t>•  Train/serve skew → a single Pipeline does clean→encode→predict, identical in training and app.</a:t>
-            </a:r>
-          </a:p>
-          <a:p>
-            <a:pPr>
-              <a:spcAft>
-                <a:spcPts val="1400"/>
-              </a:spcAft>
-            </a:pPr>
-            <a:r>
-              <a:rPr sz="1700">
-                <a:solidFill>
-                  <a:srgbClr val="0F172A"/>
-                </a:solidFill>
-                <a:latin typeface="Calibri"/>
+              <a:t>13.2%</a:t>
+            </a:r>
+          </a:p>
+        </p:txBody>
+      </p:sp>
+      <p:sp>
+        <p:nvSpPr>
+          <p:cNvPr id="7" name="Rounded Rectangle 6"/>
+          <p:cNvSpPr/>
+          <p:nvPr/>
+        </p:nvSpPr>
+        <p:spPr>
+          <a:xfrm>
+            <a:off x="5175504" y="1828800"/>
+            <a:ext cx="2103120" cy="1280160"/>
+          </a:xfrm>
+          <a:prstGeom prst="roundRect">
+            <a:avLst/>
+          </a:prstGeom>
+          <a:solidFill>
+            <a:srgbClr val="FBF7EE"/>
+          </a:solidFill>
+          <a:ln>
+            <a:solidFill>
+              <a:srgbClr val="E2E8F0"/>
+            </a:solidFill>
+          </a:ln>
+        </p:spPr>
+        <p:style>
+          <a:lnRef idx="1">
+            <a:schemeClr val="accent1"/>
+          </a:lnRef>
+          <a:fillRef idx="3">
+            <a:schemeClr val="accent1"/>
+          </a:fillRef>
+          <a:effectRef idx="2">
+            <a:schemeClr val="accent1"/>
+          </a:effectRef>
+          <a:fontRef idx="minor">
+            <a:schemeClr val="lt1"/>
+          </a:fontRef>
+        </p:style>
+        <p:txBody>
+          <a:bodyPr rtlCol="0" anchor="ctr" wrap="square"/>
+          <a:lstStyle/>
+          <a:p>
+            <a:pPr algn="ctr"/>
+            <a:r>
+              <a:rPr sz="1200">
+                <a:solidFill>
+                  <a:srgbClr val="64748B"/>
+                </a:solidFill>
               </a:rPr>
-              <a:t>•  Trust → conformal range on every quote + SHAP explanation of every driver.</a:t>
-            </a:r>
-          </a:p>
-        </p:txBody>
-      </p:sp>
+              <a:t>Median APE</a:t>
+            </a:r>
+          </a:p>
+          <a:p>
+            <a:pPr algn="ctr"/>
+            <a:r>
+              <a:rPr sz="2300" b="1">
+                <a:solidFill>
+                  <a:srgbClr val="1E3A8A"/>
+                </a:solidFill>
+              </a:rPr>
+              <a:t>9.9%</a:t>
+            </a:r>
+          </a:p>
+        </p:txBody>
+      </p:sp>
+      <p:sp>
+        <p:nvSpPr>
+          <p:cNvPr id="8" name="Rounded Rectangle 7"/>
+          <p:cNvSpPr/>
+          <p:nvPr/>
+        </p:nvSpPr>
+        <p:spPr>
+          <a:xfrm>
+            <a:off x="7443216" y="1828800"/>
+            <a:ext cx="2103120" cy="1280160"/>
+          </a:xfrm>
+          <a:prstGeom prst="roundRect">
+            <a:avLst/>
+          </a:prstGeom>
+          <a:solidFill>
+            <a:srgbClr val="FBF7EE"/>
+          </a:solidFill>
+          <a:ln>
+            <a:solidFill>
+              <a:srgbClr val="E2E8F0"/>
+            </a:solidFill>
+          </a:ln>
+        </p:spPr>
+        <p:style>
+          <a:lnRef idx="1">
+            <a:schemeClr val="accent1"/>
+          </a:lnRef>
+          <a:fillRef idx="3">
+            <a:schemeClr val="accent1"/>
+          </a:fillRef>
+          <a:effectRef idx="2">
+            <a:schemeClr val="accent1"/>
+          </a:effectRef>
+          <a:fontRef idx="minor">
+            <a:schemeClr val="lt1"/>
+          </a:fontRef>
+        </p:style>
+        <p:txBody>
+          <a:bodyPr rtlCol="0" anchor="ctr" wrap="square"/>
+          <a:lstStyle/>
+          <a:p>
+            <a:pPr algn="ctr"/>
+            <a:r>
+              <a:rPr sz="1200">
+                <a:solidFill>
+                  <a:srgbClr val="64748B"/>
+                </a:solidFill>
+              </a:rPr>
+              <a:t>MAE</a:t>
+            </a:r>
+          </a:p>
+          <a:p>
+            <a:pPr algn="ctr"/>
+            <a:r>
+              <a:rPr sz="2300" b="1">
+                <a:solidFill>
+                  <a:srgbClr val="1E3A8A"/>
+                </a:solidFill>
+              </a:rPr>
+              <a:t>$148,216</a:t>
+            </a:r>
+          </a:p>
+        </p:txBody>
+      </p:sp>
+      <p:sp>
+        <p:nvSpPr>
+          <p:cNvPr id="9" name="Rounded Rectangle 8"/>
+          <p:cNvSpPr/>
+          <p:nvPr/>
+        </p:nvSpPr>
+        <p:spPr>
+          <a:xfrm>
+            <a:off x="9710928" y="1828800"/>
+            <a:ext cx="2103120" cy="1280160"/>
+          </a:xfrm>
+          <a:prstGeom prst="roundRect">
+            <a:avLst/>
+          </a:prstGeom>
+          <a:solidFill>
+            <a:srgbClr val="FBF7EE"/>
+          </a:solidFill>
+          <a:ln>
+            <a:solidFill>
+              <a:srgbClr val="E2E8F0"/>
+            </a:solidFill>
+          </a:ln>
+        </p:spPr>
+        <p:style>
+          <a:lnRef idx="1">
+            <a:schemeClr val="accent1"/>
+          </a:lnRef>
+          <a:fillRef idx="3">
+            <a:schemeClr val="accent1"/>
+          </a:fillRef>
+          <a:effectRef idx="2">
+            <a:schemeClr val="accent1"/>
+          </a:effectRef>
+          <a:fontRef idx="minor">
+            <a:schemeClr val="lt1"/>
+          </a:fontRef>
+        </p:style>
+        <p:txBody>
+          <a:bodyPr rtlCol="0" anchor="ctr" wrap="square"/>
+          <a:lstStyle/>
+          <a:p>
+            <a:pPr algn="ctr"/>
+            <a:r>
+              <a:rPr sz="1200">
+                <a:solidFill>
+                  <a:srgbClr val="64748B"/>
+                </a:solidFill>
+              </a:rPr>
+              <a:t>90% PI coverage</a:t>
+            </a:r>
+          </a:p>
+          <a:p>
+            <a:pPr algn="ctr"/>
+            <a:r>
+              <a:rPr sz="2300" b="1">
+                <a:solidFill>
+                  <a:srgbClr val="1E3A8A"/>
+                </a:solidFill>
+              </a:rPr>
+              <a:t>90.2%</a:t>
+            </a:r>
+          </a:p>
+        </p:txBody>
+      </p:sp>
+      <p:pic>
+        <p:nvPicPr>
+          <p:cNvPr id="10" name="Picture 9" descr="actual_vs_predicted.png"/>
+          <p:cNvPicPr>
+            <a:picLocks noChangeAspect="1"/>
+          </p:cNvPicPr>
+          <p:nvPr/>
+        </p:nvPicPr>
+        <p:blipFill>
+          <a:blip r:embed="rId2"/>
+          <a:stretch>
+            <a:fillRect/>
+          </a:stretch>
+        </p:blipFill>
+        <p:spPr>
+          <a:xfrm>
+            <a:off x="3657600" y="3383280"/>
+            <a:ext cx="2973788" cy="3108960"/>
+          </a:xfrm>
+          <a:prstGeom prst="rect">
+            <a:avLst/>
+          </a:prstGeom>
+        </p:spPr>
+      </p:pic>
     </p:spTree>
   </p:cSld>
   <p:clrMapOvr>
@@ -4532,14 +4662,14 @@
         </p:nvSpPr>
         <p:spPr>
           <a:xfrm>
-            <a:off x="0" y="0"/>
-            <a:ext cx="12191695" cy="164592"/>
+            <a:off x="0" y="502920"/>
+            <a:ext cx="201168" cy="960120"/>
           </a:xfrm>
           <a:prstGeom prst="rect">
             <a:avLst/>
           </a:prstGeom>
           <a:solidFill>
-            <a:srgbClr val="2563EB"/>
+            <a:srgbClr val="F59E0B"/>
           </a:solidFill>
           <a:ln>
             <a:noFill/>
@@ -4575,8 +4705,8 @@
         </p:nvSpPr>
         <p:spPr>
           <a:xfrm>
-            <a:off x="548640" y="411480"/>
-            <a:ext cx="10972800" cy="914400"/>
+            <a:off x="502920" y="457200"/>
+            <a:ext cx="10972800" cy="365760"/>
           </a:xfrm>
           <a:prstGeom prst="rect">
             <a:avLst/>
@@ -4591,13 +4721,13 @@
           <a:p>
             <a:pPr algn="l"/>
             <a:r>
-              <a:rPr sz="3000" b="1">
-                <a:solidFill>
-                  <a:srgbClr val="1E3A8A"/>
+              <a:rPr sz="1300" b="1">
+                <a:solidFill>
+                  <a:srgbClr val="F59E0B"/>
                 </a:solidFill>
                 <a:latin typeface="Calibri"/>
               </a:rPr>
-              <a:t>Results — held-out test set</a:t>
+              <a:t>RECOMMENDATIONS &amp; IMPACT</a:t>
             </a:r>
           </a:p>
         </p:txBody>
@@ -4610,8 +4740,8 @@
         </p:nvSpPr>
         <p:spPr>
           <a:xfrm>
-            <a:off x="548640" y="1143000"/>
-            <a:ext cx="10972800" cy="548640"/>
+            <a:off x="502920" y="777240"/>
+            <a:ext cx="11155680" cy="914400"/>
           </a:xfrm>
           <a:prstGeom prst="rect">
             <a:avLst/>
@@ -4626,440 +4756,27 @@
           <a:p>
             <a:pPr algn="l"/>
             <a:r>
-              <a:rPr sz="1500" b="0">
-                <a:solidFill>
-                  <a:srgbClr val="64748B"/>
+              <a:rPr sz="2700" b="1">
+                <a:solidFill>
+                  <a:srgbClr val="1E3A8A"/>
                 </a:solidFill>
                 <a:latin typeface="Calibri"/>
               </a:rPr>
-              <a:t>Untouched 20% split; intervals calibrated on a separate fold.</a:t>
-            </a:r>
-          </a:p>
-        </p:txBody>
-      </p:sp>
-      <p:sp>
-        <p:nvSpPr>
-          <p:cNvPr id="5" name="Rounded Rectangle 4"/>
-          <p:cNvSpPr/>
-          <p:nvPr/>
-        </p:nvSpPr>
-        <p:spPr>
-          <a:xfrm>
-            <a:off x="640080" y="1828800"/>
-            <a:ext cx="2103120" cy="1280160"/>
-          </a:xfrm>
-          <a:prstGeom prst="roundRect">
-            <a:avLst/>
-          </a:prstGeom>
-          <a:solidFill>
-            <a:srgbClr val="F1F5F9"/>
-          </a:solidFill>
-          <a:ln>
-            <a:solidFill>
-              <a:srgbClr val="E2E8F0"/>
-            </a:solidFill>
-          </a:ln>
-        </p:spPr>
-        <p:style>
-          <a:lnRef idx="1">
-            <a:schemeClr val="accent1"/>
-          </a:lnRef>
-          <a:fillRef idx="3">
-            <a:schemeClr val="accent1"/>
-          </a:fillRef>
-          <a:effectRef idx="2">
-            <a:schemeClr val="accent1"/>
-          </a:effectRef>
-          <a:fontRef idx="minor">
-            <a:schemeClr val="lt1"/>
-          </a:fontRef>
-        </p:style>
-        <p:txBody>
-          <a:bodyPr rtlCol="0" anchor="ctr" wrap="square"/>
-          <a:lstStyle/>
-          <a:p>
-            <a:pPr algn="ctr"/>
-            <a:r>
-              <a:rPr sz="1200">
-                <a:solidFill>
-                  <a:srgbClr val="64748B"/>
-                </a:solidFill>
-              </a:rPr>
-              <a:t>R²</a:t>
-            </a:r>
-          </a:p>
-          <a:p>
-            <a:pPr algn="ctr"/>
-            <a:r>
-              <a:rPr sz="2400" b="1">
-                <a:solidFill>
-                  <a:srgbClr val="1E3A8A"/>
-                </a:solidFill>
-              </a:rPr>
-              <a:t>0.848</a:t>
-            </a:r>
-          </a:p>
-        </p:txBody>
-      </p:sp>
-      <p:sp>
-        <p:nvSpPr>
-          <p:cNvPr id="6" name="Rounded Rectangle 5"/>
-          <p:cNvSpPr/>
-          <p:nvPr/>
-        </p:nvSpPr>
-        <p:spPr>
-          <a:xfrm>
-            <a:off x="2907791" y="1828800"/>
-            <a:ext cx="2103120" cy="1280160"/>
-          </a:xfrm>
-          <a:prstGeom prst="roundRect">
-            <a:avLst/>
-          </a:prstGeom>
-          <a:solidFill>
-            <a:srgbClr val="F1F5F9"/>
-          </a:solidFill>
-          <a:ln>
-            <a:solidFill>
-              <a:srgbClr val="E2E8F0"/>
-            </a:solidFill>
-          </a:ln>
-        </p:spPr>
-        <p:style>
-          <a:lnRef idx="1">
-            <a:schemeClr val="accent1"/>
-          </a:lnRef>
-          <a:fillRef idx="3">
-            <a:schemeClr val="accent1"/>
-          </a:fillRef>
-          <a:effectRef idx="2">
-            <a:schemeClr val="accent1"/>
-          </a:effectRef>
-          <a:fontRef idx="minor">
-            <a:schemeClr val="lt1"/>
-          </a:fontRef>
-        </p:style>
-        <p:txBody>
-          <a:bodyPr rtlCol="0" anchor="ctr" wrap="square"/>
-          <a:lstStyle/>
-          <a:p>
-            <a:pPr algn="ctr"/>
-            <a:r>
-              <a:rPr sz="1200">
-                <a:solidFill>
-                  <a:srgbClr val="64748B"/>
-                </a:solidFill>
-              </a:rPr>
-              <a:t>MAPE</a:t>
-            </a:r>
-          </a:p>
-          <a:p>
-            <a:pPr algn="ctr"/>
-            <a:r>
-              <a:rPr sz="2400" b="1">
-                <a:solidFill>
-                  <a:srgbClr val="1E3A8A"/>
-                </a:solidFill>
-              </a:rPr>
-              <a:t>13.2%</a:t>
-            </a:r>
-          </a:p>
-        </p:txBody>
-      </p:sp>
-      <p:sp>
-        <p:nvSpPr>
-          <p:cNvPr id="7" name="Rounded Rectangle 6"/>
-          <p:cNvSpPr/>
-          <p:nvPr/>
-        </p:nvSpPr>
-        <p:spPr>
-          <a:xfrm>
-            <a:off x="5175504" y="1828800"/>
-            <a:ext cx="2103120" cy="1280160"/>
-          </a:xfrm>
-          <a:prstGeom prst="roundRect">
-            <a:avLst/>
-          </a:prstGeom>
-          <a:solidFill>
-            <a:srgbClr val="F1F5F9"/>
-          </a:solidFill>
-          <a:ln>
-            <a:solidFill>
-              <a:srgbClr val="E2E8F0"/>
-            </a:solidFill>
-          </a:ln>
-        </p:spPr>
-        <p:style>
-          <a:lnRef idx="1">
-            <a:schemeClr val="accent1"/>
-          </a:lnRef>
-          <a:fillRef idx="3">
-            <a:schemeClr val="accent1"/>
-          </a:fillRef>
-          <a:effectRef idx="2">
-            <a:schemeClr val="accent1"/>
-          </a:effectRef>
-          <a:fontRef idx="minor">
-            <a:schemeClr val="lt1"/>
-          </a:fontRef>
-        </p:style>
-        <p:txBody>
-          <a:bodyPr rtlCol="0" anchor="ctr" wrap="square"/>
-          <a:lstStyle/>
-          <a:p>
-            <a:pPr algn="ctr"/>
-            <a:r>
-              <a:rPr sz="1200">
-                <a:solidFill>
-                  <a:srgbClr val="64748B"/>
-                </a:solidFill>
-              </a:rPr>
-              <a:t>Median APE</a:t>
-            </a:r>
-          </a:p>
-          <a:p>
-            <a:pPr algn="ctr"/>
-            <a:r>
-              <a:rPr sz="2400" b="1">
-                <a:solidFill>
-                  <a:srgbClr val="1E3A8A"/>
-                </a:solidFill>
-              </a:rPr>
-              <a:t>9.9%</a:t>
-            </a:r>
-          </a:p>
-        </p:txBody>
-      </p:sp>
-      <p:sp>
-        <p:nvSpPr>
-          <p:cNvPr id="8" name="Rounded Rectangle 7"/>
-          <p:cNvSpPr/>
-          <p:nvPr/>
-        </p:nvSpPr>
-        <p:spPr>
-          <a:xfrm>
-            <a:off x="7443216" y="1828800"/>
-            <a:ext cx="2103120" cy="1280160"/>
-          </a:xfrm>
-          <a:prstGeom prst="roundRect">
-            <a:avLst/>
-          </a:prstGeom>
-          <a:solidFill>
-            <a:srgbClr val="F1F5F9"/>
-          </a:solidFill>
-          <a:ln>
-            <a:solidFill>
-              <a:srgbClr val="E2E8F0"/>
-            </a:solidFill>
-          </a:ln>
-        </p:spPr>
-        <p:style>
-          <a:lnRef idx="1">
-            <a:schemeClr val="accent1"/>
-          </a:lnRef>
-          <a:fillRef idx="3">
-            <a:schemeClr val="accent1"/>
-          </a:fillRef>
-          <a:effectRef idx="2">
-            <a:schemeClr val="accent1"/>
-          </a:effectRef>
-          <a:fontRef idx="minor">
-            <a:schemeClr val="lt1"/>
-          </a:fontRef>
-        </p:style>
-        <p:txBody>
-          <a:bodyPr rtlCol="0" anchor="ctr" wrap="square"/>
-          <a:lstStyle/>
-          <a:p>
-            <a:pPr algn="ctr"/>
-            <a:r>
-              <a:rPr sz="1200">
-                <a:solidFill>
-                  <a:srgbClr val="64748B"/>
-                </a:solidFill>
-              </a:rPr>
-              <a:t>MAE</a:t>
-            </a:r>
-          </a:p>
-          <a:p>
-            <a:pPr algn="ctr"/>
-            <a:r>
-              <a:rPr sz="2400" b="1">
-                <a:solidFill>
-                  <a:srgbClr val="1E3A8A"/>
-                </a:solidFill>
-              </a:rPr>
-              <a:t>$148,216</a:t>
-            </a:r>
-          </a:p>
-        </p:txBody>
-      </p:sp>
-      <p:sp>
-        <p:nvSpPr>
-          <p:cNvPr id="9" name="Rounded Rectangle 8"/>
-          <p:cNvSpPr/>
-          <p:nvPr/>
-        </p:nvSpPr>
-        <p:spPr>
-          <a:xfrm>
-            <a:off x="9710928" y="1828800"/>
-            <a:ext cx="2103120" cy="1280160"/>
-          </a:xfrm>
-          <a:prstGeom prst="roundRect">
-            <a:avLst/>
-          </a:prstGeom>
-          <a:solidFill>
-            <a:srgbClr val="F1F5F9"/>
-          </a:solidFill>
-          <a:ln>
-            <a:solidFill>
-              <a:srgbClr val="E2E8F0"/>
-            </a:solidFill>
-          </a:ln>
-        </p:spPr>
-        <p:style>
-          <a:lnRef idx="1">
-            <a:schemeClr val="accent1"/>
-          </a:lnRef>
-          <a:fillRef idx="3">
-            <a:schemeClr val="accent1"/>
-          </a:fillRef>
-          <a:effectRef idx="2">
-            <a:schemeClr val="accent1"/>
-          </a:effectRef>
-          <a:fontRef idx="minor">
-            <a:schemeClr val="lt1"/>
-          </a:fontRef>
-        </p:style>
-        <p:txBody>
-          <a:bodyPr rtlCol="0" anchor="ctr" wrap="square"/>
-          <a:lstStyle/>
-          <a:p>
-            <a:pPr algn="ctr"/>
-            <a:r>
-              <a:rPr sz="1200">
-                <a:solidFill>
-                  <a:srgbClr val="64748B"/>
-                </a:solidFill>
-              </a:rPr>
-              <a:t>90% PI coverage</a:t>
-            </a:r>
-          </a:p>
-          <a:p>
-            <a:pPr algn="ctr"/>
-            <a:r>
-              <a:rPr sz="2400" b="1">
-                <a:solidFill>
-                  <a:srgbClr val="1E3A8A"/>
-                </a:solidFill>
-              </a:rPr>
-              <a:t>90.2%</a:t>
-            </a:r>
-          </a:p>
-        </p:txBody>
-      </p:sp>
-      <p:pic>
-        <p:nvPicPr>
-          <p:cNvPr id="10" name="Picture 9" descr="actual_vs_predicted.png"/>
-          <p:cNvPicPr>
-            <a:picLocks noChangeAspect="1"/>
-          </p:cNvPicPr>
-          <p:nvPr/>
-        </p:nvPicPr>
-        <p:blipFill>
-          <a:blip r:embed="rId2"/>
-          <a:stretch>
-            <a:fillRect/>
-          </a:stretch>
-        </p:blipFill>
-        <p:spPr>
-          <a:xfrm>
-            <a:off x="3566160" y="3383280"/>
-            <a:ext cx="2973788" cy="3108960"/>
-          </a:xfrm>
-          <a:prstGeom prst="rect">
-            <a:avLst/>
-          </a:prstGeom>
-        </p:spPr>
-      </p:pic>
-    </p:spTree>
-  </p:cSld>
-  <p:clrMapOvr>
-    <a:masterClrMapping/>
-  </p:clrMapOvr>
-</p:sld>
-</file>
-
-<file path=ppt/slides/slide7.xml><?xml version="1.0" encoding="utf-8"?>
-<p:sld xmlns:a="http://schemas.openxmlformats.org/drawingml/2006/main" xmlns:p="http://schemas.openxmlformats.org/presentationml/2006/main" xmlns:r="http://schemas.openxmlformats.org/officeDocument/2006/relationships">
-  <p:cSld>
-    <p:bg>
-      <p:bgPr>
-        <a:solidFill>
-          <a:srgbClr val="FFFFFF"/>
-        </a:solidFill>
-        <a:effectLst/>
-      </p:bgPr>
-    </p:bg>
-    <p:spTree>
-      <p:nvGrpSpPr>
-        <p:cNvPr id="1" name=""/>
-        <p:cNvGrpSpPr/>
-        <p:nvPr/>
-      </p:nvGrpSpPr>
-      <p:grpSpPr/>
-      <p:sp>
-        <p:nvSpPr>
-          <p:cNvPr id="2" name="Rectangle 1"/>
-          <p:cNvSpPr/>
-          <p:nvPr/>
-        </p:nvSpPr>
-        <p:spPr>
-          <a:xfrm>
-            <a:off x="0" y="0"/>
-            <a:ext cx="12191695" cy="164592"/>
-          </a:xfrm>
-          <a:prstGeom prst="rect">
-            <a:avLst/>
-          </a:prstGeom>
-          <a:solidFill>
-            <a:srgbClr val="2563EB"/>
-          </a:solidFill>
-          <a:ln>
-            <a:noFill/>
-          </a:ln>
-        </p:spPr>
-        <p:style>
-          <a:lnRef idx="1">
-            <a:schemeClr val="accent1"/>
-          </a:lnRef>
-          <a:fillRef idx="3">
-            <a:schemeClr val="accent1"/>
-          </a:fillRef>
-          <a:effectRef idx="2">
-            <a:schemeClr val="accent1"/>
-          </a:effectRef>
-          <a:fontRef idx="minor">
-            <a:schemeClr val="lt1"/>
-          </a:fontRef>
-        </p:style>
-        <p:txBody>
-          <a:bodyPr rtlCol="0" anchor="ctr"/>
-          <a:lstStyle/>
-          <a:p>
-            <a:pPr algn="ctr"/>
-          </a:p>
-        </p:txBody>
-      </p:sp>
-      <p:sp>
-        <p:nvSpPr>
-          <p:cNvPr id="3" name="TextBox 2"/>
+              <a:t>From valuation to decision</a:t>
+            </a:r>
+          </a:p>
+        </p:txBody>
+      </p:sp>
+      <p:sp>
+        <p:nvSpPr>
+          <p:cNvPr id="5" name="TextBox 4"/>
           <p:cNvSpPr txBox="1"/>
           <p:nvPr/>
         </p:nvSpPr>
         <p:spPr>
           <a:xfrm>
-            <a:off x="548640" y="411480"/>
-            <a:ext cx="10972800" cy="914400"/>
+            <a:off x="640080" y="1783080"/>
+            <a:ext cx="10972800" cy="4023360"/>
           </a:xfrm>
           <a:prstGeom prst="rect">
             <a:avLst/>
@@ -5067,100 +4784,6 @@
           <a:noFill/>
         </p:spPr>
         <p:txBody>
-          <a:bodyPr wrap="square" anchor="t">
-            <a:spAutoFit/>
-          </a:bodyPr>
-          <a:lstStyle/>
-          <a:p>
-            <a:pPr algn="l"/>
-            <a:r>
-              <a:rPr sz="3000" b="1">
-                <a:solidFill>
-                  <a:srgbClr val="1E3A8A"/>
-                </a:solidFill>
-                <a:latin typeface="Calibri"/>
-              </a:rPr>
-              <a:t>Explainability — SHAP</a:t>
-            </a:r>
-          </a:p>
-        </p:txBody>
-      </p:sp>
-      <p:sp>
-        <p:nvSpPr>
-          <p:cNvPr id="4" name="TextBox 3"/>
-          <p:cNvSpPr txBox="1"/>
-          <p:nvPr/>
-        </p:nvSpPr>
-        <p:spPr>
-          <a:xfrm>
-            <a:off x="548640" y="1143000"/>
-            <a:ext cx="10972800" cy="548640"/>
-          </a:xfrm>
-          <a:prstGeom prst="rect">
-            <a:avLst/>
-          </a:prstGeom>
-          <a:noFill/>
-        </p:spPr>
-        <p:txBody>
-          <a:bodyPr wrap="square" anchor="t">
-            <a:spAutoFit/>
-          </a:bodyPr>
-          <a:lstStyle/>
-          <a:p>
-            <a:pPr algn="l"/>
-            <a:r>
-              <a:rPr sz="1500" b="0">
-                <a:solidFill>
-                  <a:srgbClr val="64748B"/>
-                </a:solidFill>
-                <a:latin typeface="Calibri"/>
-              </a:rPr>
-              <a:t>Global drivers and a per-property breakdown power the demo's 'why this valuation?'</a:t>
-            </a:r>
-          </a:p>
-        </p:txBody>
-      </p:sp>
-      <p:pic>
-        <p:nvPicPr>
-          <p:cNvPr id="5" name="Picture 4" descr="shap_importance.png"/>
-          <p:cNvPicPr>
-            <a:picLocks noChangeAspect="1"/>
-          </p:cNvPicPr>
-          <p:nvPr/>
-        </p:nvPicPr>
-        <p:blipFill>
-          <a:blip r:embed="rId2"/>
-          <a:stretch>
-            <a:fillRect/>
-          </a:stretch>
-        </p:blipFill>
-        <p:spPr>
-          <a:xfrm>
-            <a:off x="640080" y="1737360"/>
-            <a:ext cx="4784565" cy="4480560"/>
-          </a:xfrm>
-          <a:prstGeom prst="rect">
-            <a:avLst/>
-          </a:prstGeom>
-        </p:spPr>
-      </p:pic>
-      <p:sp>
-        <p:nvSpPr>
-          <p:cNvPr id="6" name="TextBox 5"/>
-          <p:cNvSpPr txBox="1"/>
-          <p:nvPr/>
-        </p:nvSpPr>
-        <p:spPr>
-          <a:xfrm>
-            <a:off x="6492240" y="2103120"/>
-            <a:ext cx="5120640" cy="3657600"/>
-          </a:xfrm>
-          <a:prstGeom prst="rect">
-            <a:avLst/>
-          </a:prstGeom>
-          <a:noFill/>
-        </p:spPr>
-        <p:txBody>
           <a:bodyPr wrap="square">
             <a:spAutoFit/>
           </a:bodyPr>
@@ -5168,331 +4791,81 @@
           <a:p>
             <a:pPr>
               <a:spcAft>
-                <a:spcPts val="1400"/>
+                <a:spcPts val="1300"/>
               </a:spcAft>
             </a:pPr>
             <a:r>
-              <a:rPr sz="1600">
+              <a:rPr sz="1700">
                 <a:solidFill>
                   <a:srgbClr val="0F172A"/>
                 </a:solidFill>
                 <a:latin typeface="Calibri"/>
               </a:rPr>
-              <a:t>•  Type (house vs unit) and distance to the CBD dominate.</a:t>
+              <a:t>•  Instant, explainable valuations for pricing, lending and portfolio monitoring.</a:t>
             </a:r>
           </a:p>
           <a:p>
             <a:pPr>
               <a:spcAft>
-                <a:spcPts val="1400"/>
+                <a:spcPts val="1300"/>
               </a:spcAft>
             </a:pPr>
             <a:r>
-              <a:rPr sz="1600">
+              <a:rPr sz="1700">
                 <a:solidFill>
                   <a:srgbClr val="0F172A"/>
                 </a:solidFill>
                 <a:latin typeface="Calibri"/>
               </a:rPr>
-              <a:t>•  Postcode &amp; suburb encode fine-grained location value.</a:t>
+              <a:t>•  Prediction intervals let underwriting act on risk, not just a point estimate.</a:t>
             </a:r>
           </a:p>
           <a:p>
             <a:pPr>
               <a:spcAft>
-                <a:spcPts val="1400"/>
+                <a:spcPts val="1300"/>
               </a:spcAft>
             </a:pPr>
             <a:r>
-              <a:rPr sz="1600">
+              <a:rPr sz="1700">
                 <a:solidFill>
                   <a:srgbClr val="0F172A"/>
                 </a:solidFill>
                 <a:latin typeface="Calibri"/>
               </a:rPr>
-              <a:t>•  Land size and bathrooms add property-level detail.</a:t>
+              <a:t>•  SHAP explanations support regulatory/customer transparency requirements.</a:t>
             </a:r>
           </a:p>
           <a:p>
             <a:pPr>
               <a:spcAft>
-                <a:spcPts val="1400"/>
+                <a:spcPts val="1300"/>
               </a:spcAft>
             </a:pPr>
             <a:r>
-              <a:rPr sz="1600">
+              <a:rPr sz="1700">
                 <a:solidFill>
                   <a:srgbClr val="0F172A"/>
                 </a:solidFill>
                 <a:latin typeface="Calibri"/>
               </a:rPr>
-              <a:t>•  Per-prediction: each factor shown as a ± % effect on that home's price.</a:t>
-            </a:r>
-          </a:p>
-        </p:txBody>
-      </p:sp>
-    </p:spTree>
-  </p:cSld>
-  <p:clrMapOvr>
-    <a:masterClrMapping/>
-  </p:clrMapOvr>
-</p:sld>
-</file>
-
-<file path=ppt/slides/slide8.xml><?xml version="1.0" encoding="utf-8"?>
-<p:sld xmlns:a="http://schemas.openxmlformats.org/drawingml/2006/main" xmlns:p="http://schemas.openxmlformats.org/presentationml/2006/main" xmlns:r="http://schemas.openxmlformats.org/officeDocument/2006/relationships">
-  <p:cSld>
-    <p:bg>
-      <p:bgPr>
-        <a:solidFill>
-          <a:srgbClr val="FFFFFF"/>
-        </a:solidFill>
-        <a:effectLst/>
-      </p:bgPr>
-    </p:bg>
-    <p:spTree>
-      <p:nvGrpSpPr>
-        <p:cNvPr id="1" name=""/>
-        <p:cNvGrpSpPr/>
-        <p:nvPr/>
-      </p:nvGrpSpPr>
-      <p:grpSpPr/>
-      <p:sp>
-        <p:nvSpPr>
-          <p:cNvPr id="2" name="Rectangle 1"/>
-          <p:cNvSpPr/>
-          <p:nvPr/>
-        </p:nvSpPr>
-        <p:spPr>
-          <a:xfrm>
-            <a:off x="0" y="0"/>
-            <a:ext cx="12191695" cy="164592"/>
-          </a:xfrm>
-          <a:prstGeom prst="rect">
-            <a:avLst/>
-          </a:prstGeom>
-          <a:solidFill>
-            <a:srgbClr val="2563EB"/>
-          </a:solidFill>
-          <a:ln>
-            <a:noFill/>
-          </a:ln>
-        </p:spPr>
-        <p:style>
-          <a:lnRef idx="1">
-            <a:schemeClr val="accent1"/>
-          </a:lnRef>
-          <a:fillRef idx="3">
-            <a:schemeClr val="accent1"/>
-          </a:fillRef>
-          <a:effectRef idx="2">
-            <a:schemeClr val="accent1"/>
-          </a:effectRef>
-          <a:fontRef idx="minor">
-            <a:schemeClr val="lt1"/>
-          </a:fontRef>
-        </p:style>
-        <p:txBody>
-          <a:bodyPr rtlCol="0" anchor="ctr"/>
-          <a:lstStyle/>
-          <a:p>
-            <a:pPr algn="ctr"/>
-          </a:p>
-        </p:txBody>
-      </p:sp>
-      <p:sp>
-        <p:nvSpPr>
-          <p:cNvPr id="3" name="TextBox 2"/>
-          <p:cNvSpPr txBox="1"/>
-          <p:nvPr/>
-        </p:nvSpPr>
-        <p:spPr>
-          <a:xfrm>
-            <a:off x="548640" y="411480"/>
-            <a:ext cx="10972800" cy="914400"/>
-          </a:xfrm>
-          <a:prstGeom prst="rect">
-            <a:avLst/>
-          </a:prstGeom>
-          <a:noFill/>
-        </p:spPr>
-        <p:txBody>
-          <a:bodyPr wrap="square" anchor="t">
-            <a:spAutoFit/>
-          </a:bodyPr>
-          <a:lstStyle/>
-          <a:p>
-            <a:pPr algn="l"/>
-            <a:r>
-              <a:rPr sz="3000" b="1">
-                <a:solidFill>
-                  <a:srgbClr val="1E3A8A"/>
+              <a:t>•  Median error ~10% with calibrated 90% coverage — decision-ready out of the box.</a:t>
+            </a:r>
+          </a:p>
+          <a:p>
+            <a:pPr>
+              <a:spcAft>
+                <a:spcPts val="1300"/>
+              </a:spcAft>
+            </a:pPr>
+            <a:r>
+              <a:rPr sz="1700">
+                <a:solidFill>
+                  <a:srgbClr val="0F172A"/>
                 </a:solidFill>
                 <a:latin typeface="Calibri"/>
               </a:rPr>
-              <a:t>What we built</a:t>
-            </a:r>
-          </a:p>
-        </p:txBody>
-      </p:sp>
-      <p:sp>
-        <p:nvSpPr>
-          <p:cNvPr id="4" name="TextBox 3"/>
-          <p:cNvSpPr txBox="1"/>
-          <p:nvPr/>
-        </p:nvSpPr>
-        <p:spPr>
-          <a:xfrm>
-            <a:off x="548640" y="1143000"/>
-            <a:ext cx="10972800" cy="548640"/>
-          </a:xfrm>
-          <a:prstGeom prst="rect">
-            <a:avLst/>
-          </a:prstGeom>
-          <a:noFill/>
-        </p:spPr>
-        <p:txBody>
-          <a:bodyPr wrap="square" anchor="t">
-            <a:spAutoFit/>
-          </a:bodyPr>
-          <a:lstStyle/>
-          <a:p>
-            <a:pPr algn="l"/>
-            <a:r>
-              <a:rPr sz="1500" b="0">
-                <a:solidFill>
-                  <a:srgbClr val="64748B"/>
-                </a:solidFill>
-                <a:latin typeface="Calibri"/>
-              </a:rPr>
-              <a:t>A bright, interactive Streamlit demo + a reproducible modelling pipeline.</a:t>
-            </a:r>
-          </a:p>
-        </p:txBody>
-      </p:sp>
-      <p:pic>
-        <p:nvPicPr>
-          <p:cNvPr id="5" name="Picture 4" descr="demo_valuation.png"/>
-          <p:cNvPicPr>
-            <a:picLocks noChangeAspect="1"/>
-          </p:cNvPicPr>
-          <p:nvPr/>
-        </p:nvPicPr>
-        <p:blipFill>
-          <a:blip r:embed="rId2"/>
-          <a:stretch>
-            <a:fillRect/>
-          </a:stretch>
-        </p:blipFill>
-        <p:spPr>
-          <a:xfrm>
-            <a:off x="548640" y="1737360"/>
-            <a:ext cx="6949440" cy="4826000"/>
-          </a:xfrm>
-          <a:prstGeom prst="rect">
-            <a:avLst/>
-          </a:prstGeom>
-        </p:spPr>
-      </p:pic>
-      <p:sp>
-        <p:nvSpPr>
-          <p:cNvPr id="6" name="TextBox 5"/>
-          <p:cNvSpPr txBox="1"/>
-          <p:nvPr/>
-        </p:nvSpPr>
-        <p:spPr>
-          <a:xfrm>
-            <a:off x="7772400" y="2011680"/>
-            <a:ext cx="4023360" cy="4114800"/>
-          </a:xfrm>
-          <a:prstGeom prst="rect">
-            <a:avLst/>
-          </a:prstGeom>
-          <a:noFill/>
-        </p:spPr>
-        <p:txBody>
-          <a:bodyPr wrap="square">
-            <a:spAutoFit/>
-          </a:bodyPr>
-          <a:lstStyle/>
-          <a:p>
-            <a:pPr>
-              <a:spcAft>
-                <a:spcPts val="1200"/>
-              </a:spcAft>
-            </a:pPr>
-            <a:r>
-              <a:rPr sz="1500">
-                <a:solidFill>
-                  <a:srgbClr val="0F172A"/>
-                </a:solidFill>
-                <a:latin typeface="Calibri"/>
-              </a:rPr>
-              <a:t>•  Enter a property → instant valuation.</a:t>
-            </a:r>
-          </a:p>
-          <a:p>
-            <a:pPr>
-              <a:spcAft>
-                <a:spcPts val="1200"/>
-              </a:spcAft>
-            </a:pPr>
-            <a:r>
-              <a:rPr sz="1500">
-                <a:solidFill>
-                  <a:srgbClr val="0F172A"/>
-                </a:solidFill>
-                <a:latin typeface="Calibri"/>
-              </a:rPr>
-              <a:t>•  Calibrated 80/90% price range.</a:t>
-            </a:r>
-          </a:p>
-          <a:p>
-            <a:pPr>
-              <a:spcAft>
-                <a:spcPts val="1200"/>
-              </a:spcAft>
-            </a:pPr>
-            <a:r>
-              <a:rPr sz="1500">
-                <a:solidFill>
-                  <a:srgbClr val="0F172A"/>
-                </a:solidFill>
-                <a:latin typeface="Calibri"/>
-              </a:rPr>
-              <a:t>•  'Why this valuation?' SHAP drivers.</a:t>
-            </a:r>
-          </a:p>
-          <a:p>
-            <a:pPr>
-              <a:spcAft>
-                <a:spcPts val="1200"/>
-              </a:spcAft>
-            </a:pPr>
-            <a:r>
-              <a:rPr sz="1500">
-                <a:solidFill>
-                  <a:srgbClr val="0F172A"/>
-                </a:solidFill>
-                <a:latin typeface="Calibri"/>
-              </a:rPr>
-              <a:t>•  Model-performance dashboard page.</a:t>
-            </a:r>
-          </a:p>
-          <a:p>
-            <a:pPr>
-              <a:spcAft>
-                <a:spcPts val="1200"/>
-              </a:spcAft>
-            </a:pPr>
-            <a:r>
-              <a:rPr sz="1500">
-                <a:solidFill>
-                  <a:srgbClr val="0F172A"/>
-                </a:solidFill>
-                <a:latin typeface="Calibri"/>
-              </a:rPr>
-              <a:t>•  Modular src/ pipeline, one-command retrain.</a:t>
+              <a:t>•  Extend with time (sale-date) trends, geospatial features and comparable-sales signals.</a:t>
             </a:r>
           </a:p>
         </p:txBody>

</xml_diff>